<commit_message>
Add GF Friendliness sections to Italy and Ireland country pages
Italy scores 9/10 and Ireland scores 8/10. Both pages updated with
full GF scoring breakdown, city score sidebars, and summary paragraphs.
Added sitemap generation script (scripts/generate-sitemap.js) to
automate sitemap rebuilds after page changes.

Co-Authored-By: Claude Opus 4.6 (1M context) <noreply@anthropic.com>
</commit_message>
<xml_diff>
--- a/travel website brainstorming.pptx
+++ b/travel website brainstorming.pptx
@@ -6,6 +6,7 @@
   </p:sldMasterIdLst>
   <p:sldIdLst>
     <p:sldId id="257" r:id="rId2"/>
+    <p:sldId id="258" r:id="rId3"/>
   </p:sldIdLst>
   <p:sldSz cx="12192000" cy="6858000"/>
   <p:notesSz cx="6858000" cy="9144000"/>
@@ -4106,6 +4107,386 @@
 </p:sld>
 </file>
 
+<file path=ppt/slides/slide2.xml><?xml version="1.0" encoding="utf-8"?>
+<p:sld xmlns:a="http://schemas.openxmlformats.org/drawingml/2006/main" xmlns:r="http://schemas.openxmlformats.org/officeDocument/2006/relationships" xmlns:p="http://schemas.openxmlformats.org/presentationml/2006/main">
+  <p:cSld>
+    <p:spTree>
+      <p:nvGrpSpPr>
+        <p:cNvPr id="1" name=""/>
+        <p:cNvGrpSpPr/>
+        <p:nvPr/>
+      </p:nvGrpSpPr>
+      <p:grpSpPr>
+        <a:xfrm>
+          <a:off x="0" y="0"/>
+          <a:ext cx="0" cy="0"/>
+          <a:chOff x="0" y="0"/>
+          <a:chExt cx="0" cy="0"/>
+        </a:xfrm>
+      </p:grpSpPr>
+      <p:sp>
+        <p:nvSpPr>
+          <p:cNvPr id="2" name="Rectangle 1">
+            <a:extLst>
+              <a:ext uri="{FF2B5EF4-FFF2-40B4-BE49-F238E27FC236}">
+                <a16:creationId xmlns:a16="http://schemas.microsoft.com/office/drawing/2014/main" id="{1DA10B97-20D3-FD17-22E6-6960111BF077}"/>
+              </a:ext>
+            </a:extLst>
+          </p:cNvPr>
+          <p:cNvSpPr/>
+          <p:nvPr/>
+        </p:nvSpPr>
+        <p:spPr>
+          <a:xfrm>
+            <a:off x="564776" y="551330"/>
+            <a:ext cx="10311041" cy="5891034"/>
+          </a:xfrm>
+          <a:prstGeom prst="rect">
+            <a:avLst/>
+          </a:prstGeom>
+          <a:solidFill>
+            <a:schemeClr val="bg1"/>
+          </a:solidFill>
+        </p:spPr>
+        <p:style>
+          <a:lnRef idx="2">
+            <a:schemeClr val="accent1">
+              <a:shade val="15000"/>
+            </a:schemeClr>
+          </a:lnRef>
+          <a:fillRef idx="1">
+            <a:schemeClr val="accent1"/>
+          </a:fillRef>
+          <a:effectRef idx="0">
+            <a:schemeClr val="accent1"/>
+          </a:effectRef>
+          <a:fontRef idx="minor">
+            <a:schemeClr val="lt1"/>
+          </a:fontRef>
+        </p:style>
+        <p:txBody>
+          <a:bodyPr rtlCol="0" anchor="t"/>
+          <a:lstStyle/>
+          <a:p>
+            <a:pPr algn="ctr"/>
+            <a:r>
+              <a:rPr lang="en-US" dirty="0">
+                <a:solidFill>
+                  <a:schemeClr val="tx1"/>
+                </a:solidFill>
+              </a:rPr>
+              <a:t>SKILLS:</a:t>
+            </a:r>
+          </a:p>
+          <a:p>
+            <a:pPr marL="285750" indent="-285750">
+              <a:buFont typeface="Arial" panose="020B0604020202020204" pitchFamily="34" charset="0"/>
+              <a:buChar char="•"/>
+            </a:pPr>
+            <a:r>
+              <a:rPr lang="en-US" dirty="0">
+                <a:solidFill>
+                  <a:schemeClr val="tx1"/>
+                </a:solidFill>
+              </a:rPr>
+              <a:t>Create new country maps with each city as a layer</a:t>
+            </a:r>
+          </a:p>
+          <a:p>
+            <a:pPr marL="742950" lvl="1" indent="-285750">
+              <a:buFont typeface="Arial" panose="020B0604020202020204" pitchFamily="34" charset="0"/>
+              <a:buChar char="•"/>
+            </a:pPr>
+            <a:r>
+              <a:rPr lang="en-US" dirty="0">
+                <a:solidFill>
+                  <a:schemeClr val="tx1"/>
+                </a:solidFill>
+              </a:rPr>
+              <a:t>Hotels with red pin, </a:t>
+            </a:r>
+            <a:r>
+              <a:rPr lang="en-US" dirty="0" err="1">
+                <a:solidFill>
+                  <a:schemeClr val="tx1"/>
+                </a:solidFill>
+              </a:rPr>
+              <a:t>etc</a:t>
+            </a:r>
+            <a:r>
+              <a:rPr lang="en-US" dirty="0">
+                <a:solidFill>
+                  <a:schemeClr val="tx1"/>
+                </a:solidFill>
+              </a:rPr>
+              <a:t> </a:t>
+            </a:r>
+            <a:r>
+              <a:rPr lang="en-US" dirty="0" err="1">
+                <a:solidFill>
+                  <a:schemeClr val="tx1"/>
+                </a:solidFill>
+              </a:rPr>
+              <a:t>etc</a:t>
+            </a:r>
+            <a:endParaRPr lang="en-US" dirty="0">
+              <a:solidFill>
+                <a:schemeClr val="tx1"/>
+              </a:solidFill>
+            </a:endParaRPr>
+          </a:p>
+          <a:p>
+            <a:pPr marL="285750" indent="-285750">
+              <a:buFont typeface="Arial" panose="020B0604020202020204" pitchFamily="34" charset="0"/>
+              <a:buChar char="•"/>
+            </a:pPr>
+            <a:r>
+              <a:rPr lang="en-US" dirty="0">
+                <a:solidFill>
+                  <a:schemeClr val="tx1"/>
+                </a:solidFill>
+              </a:rPr>
+              <a:t>Read from maps to update the excel file</a:t>
+            </a:r>
+          </a:p>
+          <a:p>
+            <a:pPr marL="742950" lvl="1" indent="-285750">
+              <a:buFont typeface="Arial" panose="020B0604020202020204" pitchFamily="34" charset="0"/>
+              <a:buChar char="•"/>
+            </a:pPr>
+            <a:r>
+              <a:rPr lang="en-US" dirty="0">
+                <a:solidFill>
+                  <a:schemeClr val="tx1"/>
+                </a:solidFill>
+              </a:rPr>
+              <a:t>Don’t allow overwrites??</a:t>
+            </a:r>
+          </a:p>
+          <a:p>
+            <a:pPr marL="742950" lvl="1" indent="-285750">
+              <a:buFont typeface="Arial" panose="020B0604020202020204" pitchFamily="34" charset="0"/>
+              <a:buChar char="•"/>
+            </a:pPr>
+            <a:r>
+              <a:rPr lang="en-US" dirty="0">
+                <a:solidFill>
+                  <a:schemeClr val="tx1"/>
+                </a:solidFill>
+              </a:rPr>
+              <a:t>Find dups</a:t>
+            </a:r>
+          </a:p>
+          <a:p>
+            <a:pPr marL="285750" indent="-285750">
+              <a:buFont typeface="Arial" panose="020B0604020202020204" pitchFamily="34" charset="0"/>
+              <a:buChar char="•"/>
+            </a:pPr>
+            <a:r>
+              <a:rPr lang="en-US" dirty="0">
+                <a:solidFill>
+                  <a:schemeClr val="tx1"/>
+                </a:solidFill>
+              </a:rPr>
+              <a:t>Search the web for each entry on my google sheet and </a:t>
+            </a:r>
+            <a:r>
+              <a:rPr lang="en-US" dirty="0" err="1">
+                <a:solidFill>
+                  <a:schemeClr val="tx1"/>
+                </a:solidFill>
+              </a:rPr>
+              <a:t>fillout</a:t>
+            </a:r>
+            <a:r>
+              <a:rPr lang="en-US" dirty="0">
+                <a:solidFill>
+                  <a:schemeClr val="tx1"/>
+                </a:solidFill>
+              </a:rPr>
+              <a:t> what I need for my sections on the city pages</a:t>
+            </a:r>
+          </a:p>
+          <a:p>
+            <a:pPr marL="285750" indent="-285750">
+              <a:buFont typeface="Arial" panose="020B0604020202020204" pitchFamily="34" charset="0"/>
+              <a:buChar char="•"/>
+            </a:pPr>
+            <a:r>
+              <a:rPr lang="en-US" dirty="0">
+                <a:solidFill>
+                  <a:schemeClr val="tx1"/>
+                </a:solidFill>
+              </a:rPr>
+              <a:t>Take my bank acct statements and mark which places I have visited</a:t>
+            </a:r>
+          </a:p>
+          <a:p>
+            <a:pPr marL="285750" indent="-285750">
+              <a:buFont typeface="Arial" panose="020B0604020202020204" pitchFamily="34" charset="0"/>
+              <a:buChar char="•"/>
+            </a:pPr>
+            <a:r>
+              <a:rPr lang="en-US" dirty="0">
+                <a:solidFill>
+                  <a:schemeClr val="tx1"/>
+                </a:solidFill>
+              </a:rPr>
+              <a:t>Text/email me if trying to overwrite something??? Or flag something I need t manually review and give me a page to do it</a:t>
+            </a:r>
+          </a:p>
+          <a:p>
+            <a:pPr marL="285750" indent="-285750">
+              <a:buFont typeface="Arial" panose="020B0604020202020204" pitchFamily="34" charset="0"/>
+              <a:buChar char="•"/>
+            </a:pPr>
+            <a:r>
+              <a:rPr lang="en-US" dirty="0">
+                <a:solidFill>
+                  <a:schemeClr val="tx1"/>
+                </a:solidFill>
+              </a:rPr>
+              <a:t>Tie all skills together into one skill that ‘updates the </a:t>
+            </a:r>
+            <a:r>
+              <a:rPr lang="en-US">
+                <a:solidFill>
+                  <a:schemeClr val="tx1"/>
+                </a:solidFill>
+              </a:rPr>
+              <a:t>whole website!’</a:t>
+            </a:r>
+            <a:endParaRPr lang="en-US" dirty="0">
+              <a:solidFill>
+                <a:schemeClr val="tx1"/>
+              </a:solidFill>
+            </a:endParaRPr>
+          </a:p>
+          <a:p>
+            <a:pPr marL="742950" lvl="1" indent="-285750">
+              <a:buFont typeface="Arial" panose="020B0604020202020204" pitchFamily="34" charset="0"/>
+              <a:buChar char="•"/>
+            </a:pPr>
+            <a:endParaRPr lang="en-US" dirty="0">
+              <a:solidFill>
+                <a:schemeClr val="tx1"/>
+              </a:solidFill>
+            </a:endParaRPr>
+          </a:p>
+          <a:p>
+            <a:pPr lvl="1"/>
+            <a:endParaRPr lang="en-US" dirty="0">
+              <a:solidFill>
+                <a:schemeClr val="tx1"/>
+              </a:solidFill>
+            </a:endParaRPr>
+          </a:p>
+          <a:p>
+            <a:pPr lvl="1"/>
+            <a:endParaRPr lang="en-US" dirty="0">
+              <a:solidFill>
+                <a:schemeClr val="tx1"/>
+              </a:solidFill>
+            </a:endParaRPr>
+          </a:p>
+          <a:p>
+            <a:pPr lvl="1"/>
+            <a:r>
+              <a:rPr lang="en-US" b="1" dirty="0">
+                <a:solidFill>
+                  <a:schemeClr val="tx1"/>
+                </a:solidFill>
+              </a:rPr>
+              <a:t>GOALS:</a:t>
+            </a:r>
+          </a:p>
+          <a:p>
+            <a:pPr marL="742950" lvl="1" indent="-285750">
+              <a:buFont typeface="Arial" panose="020B0604020202020204" pitchFamily="34" charset="0"/>
+              <a:buChar char="•"/>
+            </a:pPr>
+            <a:r>
+              <a:rPr lang="en-US" dirty="0">
+                <a:solidFill>
+                  <a:schemeClr val="tx1"/>
+                </a:solidFill>
+              </a:rPr>
+              <a:t>Create city pages for all cities</a:t>
+            </a:r>
+          </a:p>
+          <a:p>
+            <a:pPr marL="742950" lvl="1" indent="-285750">
+              <a:buFont typeface="Arial" panose="020B0604020202020204" pitchFamily="34" charset="0"/>
+              <a:buChar char="•"/>
+            </a:pPr>
+            <a:r>
+              <a:rPr lang="en-US" dirty="0">
+                <a:solidFill>
+                  <a:schemeClr val="tx1"/>
+                </a:solidFill>
+              </a:rPr>
+              <a:t>Add new city pages</a:t>
+            </a:r>
+          </a:p>
+          <a:p>
+            <a:pPr marL="742950" lvl="1" indent="-285750">
+              <a:buFont typeface="Arial" panose="020B0604020202020204" pitchFamily="34" charset="0"/>
+              <a:buChar char="•"/>
+            </a:pPr>
+            <a:r>
+              <a:rPr lang="en-US" dirty="0">
+                <a:solidFill>
+                  <a:schemeClr val="tx1"/>
+                </a:solidFill>
+              </a:rPr>
+              <a:t>Add to or edit existing city pages</a:t>
+            </a:r>
+          </a:p>
+          <a:p>
+            <a:pPr marL="285750" indent="-285750">
+              <a:buFont typeface="Arial" panose="020B0604020202020204" pitchFamily="34" charset="0"/>
+              <a:buChar char="•"/>
+            </a:pPr>
+            <a:endParaRPr lang="en-US" dirty="0">
+              <a:solidFill>
+                <a:schemeClr val="tx1"/>
+              </a:solidFill>
+            </a:endParaRPr>
+          </a:p>
+          <a:p>
+            <a:pPr marL="742950" lvl="1" indent="-285750">
+              <a:buFont typeface="Arial" panose="020B0604020202020204" pitchFamily="34" charset="0"/>
+              <a:buChar char="•"/>
+            </a:pPr>
+            <a:endParaRPr lang="en-US" dirty="0">
+              <a:solidFill>
+                <a:schemeClr val="tx1"/>
+              </a:solidFill>
+            </a:endParaRPr>
+          </a:p>
+          <a:p>
+            <a:pPr algn="ctr"/>
+            <a:endParaRPr lang="en-US" dirty="0">
+              <a:solidFill>
+                <a:schemeClr val="tx1"/>
+              </a:solidFill>
+            </a:endParaRPr>
+          </a:p>
+        </p:txBody>
+      </p:sp>
+    </p:spTree>
+    <p:extLst>
+      <p:ext uri="{BB962C8B-B14F-4D97-AF65-F5344CB8AC3E}">
+        <p14:creationId xmlns:p14="http://schemas.microsoft.com/office/powerpoint/2010/main" val="4012890179"/>
+      </p:ext>
+    </p:extLst>
+  </p:cSld>
+  <p:clrMapOvr>
+    <a:masterClrMapping/>
+  </p:clrMapOvr>
+</p:sld>
+</file>
+
 <file path=ppt/theme/theme1.xml><?xml version="1.0" encoding="utf-8"?>
 <a:theme xmlns:a="http://schemas.openxmlformats.org/drawingml/2006/main" name="Office Theme">
   <a:themeElements>

</xml_diff>